<commit_message>
fix(pitch): full re-verification pass — all twelve slides clean
Re-inspected every slide after the previous fix round rather than only the five
already checked. Eleven were clean; slide 7's left card ran empty at the bottom
while the right card filled. Balanced it with the line that belonged there
anyway — SourceTier.UNVERIFIED → permits() == False, the code that did the
refusing — landing at the same height as the right card's circular quote, and
dropped the card title a half point so it no longer runs edge to edge.

Co-Authored-By: Claude Opus 5 (1M context) <noreply@anthropic.com>
</commit_message>
<xml_diff>
--- a/docs/pitch/amanat-deck.pptx
+++ b/docs/pitch/amanat-deck.pptx
@@ -7760,23 +7760,23 @@
         <p:spPr>
           <a:xfrm>
             <a:off x="914400" y="1591056"/>
-            <a:ext cx="3337560" cy="457200"/>
-          </a:xfrm>
-          <a:prstGeom prst="rect">
-            <a:avLst/>
-          </a:prstGeom>
-          <a:noFill/>
-          <a:ln/>
-        </p:spPr>
-        <p:txBody>
-          <a:bodyPr wrap="square" lIns="0" tIns="0" rIns="0" bIns="0" rtlCol="0" anchor="ctr"/>
-          <a:lstStyle/>
-          <a:p>
-            <a:pPr indent="0" marL="0">
-              <a:buNone/>
-            </a:pPr>
-            <a:r>
-              <a:rPr lang="en-US" sz="1050" b="1" dirty="0">
+            <a:ext cx="3337560" cy="274320"/>
+          </a:xfrm>
+          <a:prstGeom prst="rect">
+            <a:avLst/>
+          </a:prstGeom>
+          <a:noFill/>
+          <a:ln/>
+        </p:spPr>
+        <p:txBody>
+          <a:bodyPr wrap="square" lIns="0" tIns="0" rIns="0" bIns="0" rtlCol="0" anchor="ctr"/>
+          <a:lstStyle/>
+          <a:p>
+            <a:pPr indent="0" marL="0">
+              <a:buNone/>
+            </a:pPr>
+            <a:r>
+              <a:rPr lang="en-US" sz="1000" b="1" dirty="0">
                 <a:solidFill>
                   <a:srgbClr val="1D1C1A"/>
                 </a:solidFill>
@@ -7786,7 +7786,7 @@
               </a:rPr>
               <a:t>For one day, it refused its own mechanism</a:t>
             </a:r>
-            <a:endParaRPr lang="en-US" sz="1050" dirty="0"/>
+            <a:endParaRPr lang="en-US" sz="1000" dirty="0"/>
           </a:p>
         </p:txBody>
       </p:sp>
@@ -7798,8 +7798,8 @@
         </p:nvSpPr>
         <p:spPr>
           <a:xfrm>
-            <a:off x="914400" y="2066544"/>
-            <a:ext cx="3337560" cy="868680"/>
+            <a:off x="914400" y="1920240"/>
+            <a:ext cx="3337560" cy="658368"/>
           </a:xfrm>
           <a:prstGeom prst="rect">
             <a:avLst/>
@@ -7831,7 +7831,46 @@
       </p:sp>
       <p:sp>
         <p:nvSpPr>
-          <p:cNvPr id="8" name="Shape 6"/>
+          <p:cNvPr id="8" name="Text 6"/>
+          <p:cNvSpPr/>
+          <p:nvPr/>
+        </p:nvSpPr>
+        <p:spPr>
+          <a:xfrm>
+            <a:off x="914400" y="2615184"/>
+            <a:ext cx="3337560" cy="274320"/>
+          </a:xfrm>
+          <a:prstGeom prst="rect">
+            <a:avLst/>
+          </a:prstGeom>
+          <a:noFill/>
+          <a:ln/>
+        </p:spPr>
+        <p:txBody>
+          <a:bodyPr wrap="square" lIns="0" tIns="0" rIns="0" bIns="0" rtlCol="0" anchor="t"/>
+          <a:lstStyle/>
+          <a:p>
+            <a:pPr indent="0" marL="0">
+              <a:buNone/>
+            </a:pPr>
+            <a:r>
+              <a:rPr lang="en-US" sz="880" dirty="0">
+                <a:solidFill>
+                  <a:srgbClr val="7D7970"/>
+                </a:solidFill>
+                <a:latin typeface="IBM Plex Mono" pitchFamily="34" charset="0"/>
+                <a:ea typeface="IBM Plex Mono" pitchFamily="34" charset="-122"/>
+                <a:cs typeface="IBM Plex Mono" pitchFamily="34" charset="-120"/>
+              </a:rPr>
+              <a:t>SourceTier.UNVERIFIED  →  permits() == False</a:t>
+            </a:r>
+            <a:endParaRPr lang="en-US" sz="880" dirty="0"/>
+          </a:p>
+        </p:txBody>
+      </p:sp>
+      <p:sp>
+        <p:nvSpPr>
+          <p:cNvPr id="9" name="Shape 7"/>
           <p:cNvSpPr/>
           <p:nvPr/>
         </p:nvSpPr>
@@ -7856,7 +7895,7 @@
       </p:sp>
       <p:sp>
         <p:nvSpPr>
-          <p:cNvPr id="9" name="Text 7"/>
+          <p:cNvPr id="10" name="Text 8"/>
           <p:cNvSpPr/>
           <p:nvPr/>
         </p:nvSpPr>
@@ -7895,7 +7934,7 @@
       </p:sp>
       <p:sp>
         <p:nvSpPr>
-          <p:cNvPr id="10" name="Text 8"/>
+          <p:cNvPr id="11" name="Text 9"/>
           <p:cNvSpPr/>
           <p:nvPr/>
         </p:nvSpPr>
@@ -7934,7 +7973,7 @@
       </p:sp>
       <p:sp>
         <p:nvSpPr>
-          <p:cNvPr id="11" name="Text 9"/>
+          <p:cNvPr id="12" name="Text 10"/>
           <p:cNvSpPr/>
           <p:nvPr/>
         </p:nvSpPr>
@@ -7973,7 +8012,7 @@
       </p:sp>
       <p:sp>
         <p:nvSpPr>
-          <p:cNvPr id="12" name="Shape 10"/>
+          <p:cNvPr id="13" name="Shape 11"/>
           <p:cNvSpPr/>
           <p:nvPr/>
         </p:nvSpPr>
@@ -7993,7 +8032,7 @@
       </p:sp>
       <p:sp>
         <p:nvSpPr>
-          <p:cNvPr id="13" name="Text 11"/>
+          <p:cNvPr id="14" name="Text 12"/>
           <p:cNvSpPr/>
           <p:nvPr/>
         </p:nvSpPr>
@@ -8046,7 +8085,7 @@
       </p:sp>
       <p:sp>
         <p:nvSpPr>
-          <p:cNvPr id="14" name="Text 12"/>
+          <p:cNvPr id="15" name="Text 13"/>
           <p:cNvSpPr/>
           <p:nvPr/>
         </p:nvSpPr>

</xml_diff>

<commit_message>
docs: put the live-rail result in the README and pitch deck
The mechanism now executing on a real rail is the strongest evidence in the
project, so it leads where the story is told.

- README: the "what it does" section becomes three real rails measured, not
  two (SBMD legal by circular, Cashfree executed live HTTP 200, Razorpay
  refused HTTP 400); a sixth finding — the one positive result; evidence
  table to 28 capabilities with Cashfree at 4 OBSERVED; test count 207; the
  simulator limitation rewritten to say the mechanism itself is no longer
  simulator-only.
- deck: the "Measured" slide leads with Cashfree HTTP 200 over Razorpay's
  400; architecture RAIL node shows the live rail; counts updated (207, 28).

Co-Authored-By: Claude Opus 4.8 <noreply@anthropic.com>
Claude-Session: https://claude.ai/code/session_01MFawUNS1s5wvMq6bu9XEaU
</commit_message>
<xml_diff>
--- a/docs/pitch/amanat-deck.pptx
+++ b/docs/pitch/amanat-deck.pptx
@@ -2272,7 +2272,7 @@
                 <a:ea typeface="IBM Plex Mono" pitchFamily="34" charset="-122"/>
                 <a:cs typeface="IBM Plex Mono" pitchFamily="34" charset="-120"/>
               </a:rPr>
-              <a:t>205</a:t>
+              <a:t>207</a:t>
             </a:r>
             <a:endParaRPr lang="en-US" sz="3400" dirty="0"/>
           </a:p>
@@ -2506,7 +2506,7 @@
                 <a:ea typeface="IBM Plex Mono" pitchFamily="34" charset="-122"/>
                 <a:cs typeface="IBM Plex Mono" pitchFamily="34" charset="-120"/>
               </a:rPr>
-              <a:t>26</a:t>
+              <a:t>28</a:t>
             </a:r>
             <a:endParaRPr lang="en-US" sz="3400" dirty="0"/>
           </a:p>
@@ -3089,7 +3089,7 @@
                 <a:ea typeface="IBM Plex Mono" pitchFamily="34" charset="-122"/>
                 <a:cs typeface="IBM Plex Mono" pitchFamily="34" charset="-120"/>
               </a:rPr>
-              <a:t>python -m amanat.rails.settle</a:t>
+              <a:t>python -m amanat.rails.probe_cashfree</a:t>
             </a:r>
             <a:endParaRPr lang="en-US" sz="1000" dirty="0"/>
           </a:p>
@@ -3109,7 +3109,7 @@
                 <a:ea typeface="IBM Plex Mono" pitchFamily="34" charset="-122"/>
                 <a:cs typeface="IBM Plex Mono" pitchFamily="34" charset="-120"/>
               </a:rPr>
-              <a:t>  a real run on Razorpay test APIs</a:t>
+              <a:t>  the mechanism, live on a real rail</a:t>
             </a:r>
             <a:endParaRPr lang="en-US" sz="1000" dirty="0"/>
           </a:p>
@@ -3317,7 +3317,7 @@
                 <a:ea typeface="Lato" pitchFamily="34" charset="-122"/>
                 <a:cs typeface="Lato" pitchFamily="34" charset="-120"/>
               </a:rPr>
-              <a:t>The SBMD demo runs on a simulator.</a:t>
+              <a:t>The SBMD path runs on a simulator — the mechanism does not.</a:t>
             </a:r>
             <a:endParaRPr lang="en-US" sz="1100" dirty="0"/>
           </a:p>
@@ -3356,7 +3356,7 @@
                 <a:ea typeface="Lato" pitchFamily="34" charset="-122"/>
                 <a:cs typeface="Lato" pitchFamily="34" charset="-120"/>
               </a:rPr>
-              <a:t>Every semantic cites the circular it models; the real-rail run is gated on PSP enablement. The real Razorpay path is the different-but-honest capture-then-refund.</a:t>
+              <a:t>SBMD access needs PSP enablement, so that path is simulated (every semantic cites its circular). But block → partial-debit → release was measured end to end on Cashfree’s UPI pre-auth sandbox: ₹470 of ₹620, HTTP 200.</a:t>
             </a:r>
             <a:endParaRPr lang="en-US" sz="950" dirty="0"/>
           </a:p>
@@ -7182,7 +7182,7 @@
                 <a:ea typeface="Lato" pitchFamily="34" charset="-122"/>
                 <a:cs typeface="Lato" pitchFamily="34" charset="-120"/>
               </a:rPr>
-              <a:t>block → debit → release</a:t>
+              <a:t>block → debit → release · live on Cashfree</a:t>
             </a:r>
             <a:endParaRPr lang="en-US" sz="760" dirty="0"/>
           </a:p>
@@ -8077,7 +8077,7 @@
                 <a:ea typeface="Lato" pitchFamily="34" charset="-122"/>
                 <a:cs typeface="Lato" pitchFamily="34" charset="-120"/>
               </a:rPr>
-              <a:t>PRIMARY (circulars) · OBSERVED (the live API’s own response) · SECONDARY (PSP docs) are usable as fact. MARKETING and UNVERIFIED never are — 26 capabilities across 5 rails, every one cited or refused.</a:t>
+              <a:t>PRIMARY (circulars) · OBSERVED (the live API’s own response) · SECONDARY (PSP docs) are usable as fact. MARKETING and UNVERIFIED never are — 28 capabilities across 5 rails, every one cited or refused.</a:t>
             </a:r>
             <a:endParaRPr lang="en-US" sz="1150" dirty="0"/>
           </a:p>
@@ -8246,7 +8246,7 @@
                 <a:ea typeface="IBM Plex Mono" pitchFamily="34" charset="-122"/>
                 <a:cs typeface="IBM Plex Mono" pitchFamily="34" charset="-120"/>
               </a:rPr>
-              <a:t>A doc says should. A probe says did.</a:t>
+              <a:t>Two real rails: one accepts, one refuses.</a:t>
             </a:r>
             <a:endParaRPr lang="en-US" sz="2500" dirty="0"/>
           </a:p>
@@ -8425,7 +8425,7 @@
                 <a:ea typeface="Lato" pitchFamily="34" charset="-122"/>
                 <a:cs typeface="Lato" pitchFamily="34" charset="-120"/>
               </a:rPr>
-              <a:t>Razorpay · partial capture</a:t>
+              <a:t>Cashfree · UPI pre-auth debit</a:t>
             </a:r>
             <a:endParaRPr lang="en-US" sz="1050" dirty="0"/>
           </a:p>
@@ -8458,13 +8458,13 @@
             <a:r>
               <a:rPr lang="en-US" sz="1250" b="1" dirty="0">
                 <a:solidFill>
-                  <a:srgbClr val="C03A2B"/>
+                  <a:srgbClr val="1E7B46"/>
                 </a:solidFill>
                 <a:latin typeface="IBM Plex Mono" pitchFamily="34" charset="0"/>
                 <a:ea typeface="IBM Plex Mono" pitchFamily="34" charset="-122"/>
                 <a:cs typeface="IBM Plex Mono" pitchFamily="34" charset="-120"/>
               </a:rPr>
-              <a:t>HTTP 400</a:t>
+              <a:t>HTTP 200</a:t>
             </a:r>
             <a:endParaRPr lang="en-US" sz="1250" dirty="0"/>
           </a:p>
@@ -8503,7 +8503,7 @@
                 <a:ea typeface="Lato" pitchFamily="34" charset="-122"/>
                 <a:cs typeface="Lato" pitchFamily="34" charset="-120"/>
               </a:rPr>
-              <a:t>“Capture amount must be equal to the amount authorized” — the live rail and the docs agree word for word.</a:t>
+              <a:t>captured ₹470 of a ₹620 hold; the ₹150 auto-returned — amount-contingent settlement, accepted live on a regulated UPI rail.</a:t>
             </a:r>
             <a:endParaRPr lang="en-US" sz="980" dirty="0"/>
           </a:p>
@@ -8565,7 +8565,7 @@
                 <a:ea typeface="Lato" pitchFamily="34" charset="-122"/>
                 <a:cs typeface="Lato" pitchFamily="34" charset="-120"/>
               </a:rPr>
-              <a:t>Setu UMAP · reachability</a:t>
+              <a:t>Razorpay · partial capture</a:t>
             </a:r>
             <a:endParaRPr lang="en-US" sz="1050" dirty="0"/>
           </a:p>
@@ -8598,13 +8598,13 @@
             <a:r>
               <a:rPr lang="en-US" sz="1250" b="1" dirty="0">
                 <a:solidFill>
-                  <a:srgbClr val="C2622C"/>
+                  <a:srgbClr val="C03A2B"/>
                 </a:solidFill>
                 <a:latin typeface="IBM Plex Mono" pitchFamily="34" charset="0"/>
                 <a:ea typeface="IBM Plex Mono" pitchFamily="34" charset="-122"/>
                 <a:cs typeface="IBM Plex Mono" pitchFamily="34" charset="-120"/>
               </a:rPr>
-              <a:t>NXDOMAIN</a:t>
+              <a:t>HTTP 400</a:t>
             </a:r>
             <a:endParaRPr lang="en-US" sz="1250" dirty="0"/>
           </a:p>
@@ -8643,7 +8643,7 @@
                 <a:ea typeface="Lato" pitchFamily="34" charset="-122"/>
                 <a:cs typeface="Lato" pitchFamily="34" charset="-120"/>
               </a:rPr>
-              <a:t>credentials accepted (HTTP 200) — but uatapi.setu.co / api.setu.co resolve on neither Google nor Cloudflare DNS.</a:t>
+              <a:t>the identical shape, refused: “Capture amount must be equal to the amount authorized” — live rail and docs agree word for word.</a:t>
             </a:r>
             <a:endParaRPr lang="en-US" sz="980" dirty="0"/>
           </a:p>
@@ -8845,7 +8845,7 @@
                 <a:ea typeface="Lato" pitchFamily="34" charset="-122"/>
                 <a:cs typeface="Lato" pitchFamily="34" charset="-120"/>
               </a:rPr>
-              <a:t>NPCI OC-228 · block cap</a:t>
+              <a:t>Setu UMAP · reachability</a:t>
             </a:r>
             <a:endParaRPr lang="en-US" sz="1050" dirty="0"/>
           </a:p>
@@ -8878,13 +8878,13 @@
             <a:r>
               <a:rPr lang="en-US" sz="1250" b="1" dirty="0">
                 <a:solidFill>
-                  <a:srgbClr val="1D1C1A"/>
+                  <a:srgbClr val="C2622C"/>
                 </a:solidFill>
                 <a:latin typeface="IBM Plex Mono" pitchFamily="34" charset="0"/>
                 <a:ea typeface="IBM Plex Mono" pitchFamily="34" charset="-122"/>
                 <a:cs typeface="IBM Plex Mono" pitchFamily="34" charset="-120"/>
               </a:rPr>
-              <a:t>₹10,000</a:t>
+              <a:t>NXDOMAIN</a:t>
             </a:r>
             <a:endParaRPr lang="en-US" sz="1250" dirty="0"/>
           </a:p>
@@ -8923,7 +8923,7 @@
                 <a:ea typeface="Lato" pitchFamily="34" charset="-122"/>
                 <a:cs typeface="Lato" pitchFamily="34" charset="-120"/>
               </a:rPr>
-              <a:t>read from the scanned circular, enforced in code — a reserve above it is refused with the quote attached.</a:t>
+              <a:t>credentials accepted (HTTP 200) — but uatapi.setu.co / api.setu.co resolve on neither Google nor Cloudflare DNS.</a:t>
             </a:r>
             <a:endParaRPr lang="en-US" sz="980" dirty="0"/>
           </a:p>
@@ -8985,7 +8985,7 @@
                 <a:ea typeface="Lato" pitchFamily="34" charset="-122"/>
                 <a:cs typeface="Lato" pitchFamily="34" charset="-120"/>
               </a:rPr>
-              <a:t>Reproduce: python -m amanat.rails.probe · python -m amanat.rails.settle — test mode throughout; no real money moved.</a:t>
+              <a:t>Reproduce: python -m amanat.rails.probe_cashfree · python -m amanat.rails.probe · python -m amanat.rails.settle — sandbox throughout; no real money moved.</a:t>
             </a:r>
             <a:endParaRPr lang="en-US" sz="900" dirty="0"/>
           </a:p>

</xml_diff>